<commit_message>
Add slide to link to download
</commit_message>
<xml_diff>
--- a/TechMentor/2026/workshop/THOL01-PowerShell-Toolmaking.pptx
+++ b/TechMentor/2026/workshop/THOL01-PowerShell-Toolmaking.pptx
@@ -5,29 +5,30 @@
     <p:sldMasterId id="2147483682" r:id="rId1"/>
   </p:sldMasterIdLst>
   <p:notesMasterIdLst>
-    <p:notesMasterId r:id="rId19"/>
+    <p:notesMasterId r:id="rId20"/>
   </p:notesMasterIdLst>
   <p:handoutMasterIdLst>
-    <p:handoutMasterId r:id="rId20"/>
+    <p:handoutMasterId r:id="rId21"/>
   </p:handoutMasterIdLst>
   <p:sldIdLst>
     <p:sldId id="258" r:id="rId2"/>
     <p:sldId id="275" r:id="rId3"/>
     <p:sldId id="263" r:id="rId4"/>
     <p:sldId id="264" r:id="rId5"/>
-    <p:sldId id="265" r:id="rId6"/>
-    <p:sldId id="289" r:id="rId7"/>
-    <p:sldId id="296" r:id="rId8"/>
-    <p:sldId id="290" r:id="rId9"/>
-    <p:sldId id="299" r:id="rId10"/>
-    <p:sldId id="300" r:id="rId11"/>
-    <p:sldId id="301" r:id="rId12"/>
-    <p:sldId id="297" r:id="rId13"/>
-    <p:sldId id="292" r:id="rId14"/>
-    <p:sldId id="302" r:id="rId15"/>
-    <p:sldId id="294" r:id="rId16"/>
-    <p:sldId id="304" r:id="rId17"/>
-    <p:sldId id="303" r:id="rId18"/>
+    <p:sldId id="305" r:id="rId6"/>
+    <p:sldId id="265" r:id="rId7"/>
+    <p:sldId id="289" r:id="rId8"/>
+    <p:sldId id="296" r:id="rId9"/>
+    <p:sldId id="290" r:id="rId10"/>
+    <p:sldId id="299" r:id="rId11"/>
+    <p:sldId id="300" r:id="rId12"/>
+    <p:sldId id="301" r:id="rId13"/>
+    <p:sldId id="297" r:id="rId14"/>
+    <p:sldId id="292" r:id="rId15"/>
+    <p:sldId id="302" r:id="rId16"/>
+    <p:sldId id="294" r:id="rId17"/>
+    <p:sldId id="304" r:id="rId18"/>
+    <p:sldId id="303" r:id="rId19"/>
   </p:sldIdLst>
   <p:sldSz cx="9144000" cy="5143500" type="screen16x9"/>
   <p:notesSz cx="6858000" cy="9144000"/>
@@ -25498,7 +25499,7 @@
             <a:fld id="{DE326DE0-BACA-4EA0-B73F-CC7DC1D7F4A1}" type="slidenum">
               <a:rPr lang="en-US" smtClean="0"/>
               <a:pPr/>
-              <a:t>8</a:t>
+              <a:t>9</a:t>
             </a:fld>
             <a:endParaRPr lang="en-US"/>
           </a:p>
@@ -25696,7 +25697,7 @@
           <a:p>
             <a:fld id="{D088F999-7A4E-6B4F-9FED-EF75B73AD044}" type="datetimeFigureOut">
               <a:rPr lang="en-US" smtClean="0"/>
-              <a:t>7/28/2026</a:t>
+              <a:t>7/29/2026</a:t>
             </a:fld>
             <a:endParaRPr lang="en-US"/>
           </a:p>
@@ -25864,7 +25865,7 @@
           <a:p>
             <a:fld id="{D088F999-7A4E-6B4F-9FED-EF75B73AD044}" type="datetimeFigureOut">
               <a:rPr lang="en-US" smtClean="0"/>
-              <a:t>7/28/2026</a:t>
+              <a:t>7/29/2026</a:t>
             </a:fld>
             <a:endParaRPr lang="en-US"/>
           </a:p>
@@ -26042,7 +26043,7 @@
           <a:p>
             <a:fld id="{D088F999-7A4E-6B4F-9FED-EF75B73AD044}" type="datetimeFigureOut">
               <a:rPr lang="en-US" smtClean="0"/>
-              <a:t>7/28/2026</a:t>
+              <a:t>7/29/2026</a:t>
             </a:fld>
             <a:endParaRPr lang="en-US"/>
           </a:p>
@@ -26210,7 +26211,7 @@
           <a:p>
             <a:fld id="{D088F999-7A4E-6B4F-9FED-EF75B73AD044}" type="datetimeFigureOut">
               <a:rPr lang="en-US" smtClean="0"/>
-              <a:t>7/28/2026</a:t>
+              <a:t>7/29/2026</a:t>
             </a:fld>
             <a:endParaRPr lang="en-US"/>
           </a:p>
@@ -26455,7 +26456,7 @@
           <a:p>
             <a:fld id="{D088F999-7A4E-6B4F-9FED-EF75B73AD044}" type="datetimeFigureOut">
               <a:rPr lang="en-US" smtClean="0"/>
-              <a:t>7/28/2026</a:t>
+              <a:t>7/29/2026</a:t>
             </a:fld>
             <a:endParaRPr lang="en-US"/>
           </a:p>
@@ -26740,7 +26741,7 @@
           <a:p>
             <a:fld id="{D088F999-7A4E-6B4F-9FED-EF75B73AD044}" type="datetimeFigureOut">
               <a:rPr lang="en-US" smtClean="0"/>
-              <a:t>7/28/2026</a:t>
+              <a:t>7/29/2026</a:t>
             </a:fld>
             <a:endParaRPr lang="en-US"/>
           </a:p>
@@ -27159,7 +27160,7 @@
           <a:p>
             <a:fld id="{D088F999-7A4E-6B4F-9FED-EF75B73AD044}" type="datetimeFigureOut">
               <a:rPr lang="en-US" smtClean="0"/>
-              <a:t>7/28/2026</a:t>
+              <a:t>7/29/2026</a:t>
             </a:fld>
             <a:endParaRPr lang="en-US"/>
           </a:p>
@@ -27276,7 +27277,7 @@
           <a:p>
             <a:fld id="{D088F999-7A4E-6B4F-9FED-EF75B73AD044}" type="datetimeFigureOut">
               <a:rPr lang="en-US" smtClean="0"/>
-              <a:t>7/28/2026</a:t>
+              <a:t>7/29/2026</a:t>
             </a:fld>
             <a:endParaRPr lang="en-US"/>
           </a:p>
@@ -27371,7 +27372,7 @@
           <a:p>
             <a:fld id="{D088F999-7A4E-6B4F-9FED-EF75B73AD044}" type="datetimeFigureOut">
               <a:rPr lang="en-US" smtClean="0"/>
-              <a:t>7/28/2026</a:t>
+              <a:t>7/29/2026</a:t>
             </a:fld>
             <a:endParaRPr lang="en-US"/>
           </a:p>
@@ -27646,7 +27647,7 @@
           <a:p>
             <a:fld id="{D088F999-7A4E-6B4F-9FED-EF75B73AD044}" type="datetimeFigureOut">
               <a:rPr lang="en-US" smtClean="0"/>
-              <a:t>7/28/2026</a:t>
+              <a:t>7/29/2026</a:t>
             </a:fld>
             <a:endParaRPr lang="en-US"/>
           </a:p>
@@ -27898,7 +27899,7 @@
           <a:p>
             <a:fld id="{D088F999-7A4E-6B4F-9FED-EF75B73AD044}" type="datetimeFigureOut">
               <a:rPr lang="en-US" smtClean="0"/>
-              <a:t>7/28/2026</a:t>
+              <a:t>7/29/2026</a:t>
             </a:fld>
             <a:endParaRPr lang="en-US"/>
           </a:p>
@@ -28118,7 +28119,7 @@
           <a:p>
             <a:fld id="{D088F999-7A4E-6B4F-9FED-EF75B73AD044}" type="datetimeFigureOut">
               <a:rPr lang="en-US" smtClean="0"/>
-              <a:t>7/28/2026</a:t>
+              <a:t>7/29/2026</a:t>
             </a:fld>
             <a:endParaRPr lang="en-US"/>
           </a:p>
@@ -29244,6 +29245,95 @@
           <p:cNvPr id="2" name="Title 1">
             <a:extLst>
               <a:ext uri="{FF2B5EF4-FFF2-40B4-BE49-F238E27FC236}">
+                <a16:creationId xmlns:a16="http://schemas.microsoft.com/office/drawing/2014/main" id="{B53E042C-9C01-11B7-FADC-AF3C17430252}"/>
+              </a:ext>
+            </a:extLst>
+          </p:cNvPr>
+          <p:cNvSpPr>
+            <a:spLocks noGrp="1"/>
+          </p:cNvSpPr>
+          <p:nvPr>
+            <p:ph type="title"/>
+          </p:nvPr>
+        </p:nvSpPr>
+        <p:spPr/>
+        <p:txBody>
+          <a:bodyPr/>
+          <a:lstStyle/>
+          <a:p>
+            <a:r>
+              <a:rPr lang="en-US" dirty="0"/>
+              <a:t>Command design</a:t>
+            </a:r>
+          </a:p>
+        </p:txBody>
+      </p:sp>
+      <p:graphicFrame>
+        <p:nvGraphicFramePr>
+          <p:cNvPr id="4" name="Content Placeholder 3">
+            <a:extLst>
+              <a:ext uri="{FF2B5EF4-FFF2-40B4-BE49-F238E27FC236}">
+                <a16:creationId xmlns:a16="http://schemas.microsoft.com/office/drawing/2014/main" id="{0114C13B-9F4B-1331-0A9E-CBD62A44A869}"/>
+              </a:ext>
+            </a:extLst>
+          </p:cNvPr>
+          <p:cNvGraphicFramePr>
+            <a:graphicFrameLocks noGrp="1"/>
+          </p:cNvGraphicFramePr>
+          <p:nvPr>
+            <p:ph idx="1"/>
+            <p:extLst>
+              <p:ext uri="{D42A27DB-BD31-4B8C-83A1-F6EECF244321}">
+                <p14:modId xmlns:p14="http://schemas.microsoft.com/office/powerpoint/2010/main" val="1789930414"/>
+              </p:ext>
+            </p:extLst>
+          </p:nvPr>
+        </p:nvGraphicFramePr>
+        <p:xfrm>
+          <a:off x="457200" y="1200150"/>
+          <a:ext cx="8229600" cy="3394075"/>
+        </p:xfrm>
+        <a:graphic>
+          <a:graphicData uri="http://schemas.openxmlformats.org/drawingml/2006/diagram">
+            <dgm:relIds xmlns:dgm="http://schemas.openxmlformats.org/drawingml/2006/diagram" xmlns:r="http://schemas.openxmlformats.org/officeDocument/2006/relationships" r:dm="rId2" r:lo="rId3" r:qs="rId4" r:cs="rId5"/>
+          </a:graphicData>
+        </a:graphic>
+      </p:graphicFrame>
+    </p:spTree>
+    <p:extLst>
+      <p:ext uri="{BB962C8B-B14F-4D97-AF65-F5344CB8AC3E}">
+        <p14:creationId xmlns:p14="http://schemas.microsoft.com/office/powerpoint/2010/main" val="1497520819"/>
+      </p:ext>
+    </p:extLst>
+  </p:cSld>
+  <p:clrMapOvr>
+    <a:masterClrMapping/>
+  </p:clrMapOvr>
+</p:sld>
+</file>
+
+<file path=ppt/slides/slide11.xml><?xml version="1.0" encoding="utf-8"?>
+<p:sld xmlns:a="http://schemas.openxmlformats.org/drawingml/2006/main" xmlns:r="http://schemas.openxmlformats.org/officeDocument/2006/relationships" xmlns:p="http://schemas.openxmlformats.org/presentationml/2006/main">
+  <p:cSld>
+    <p:spTree>
+      <p:nvGrpSpPr>
+        <p:cNvPr id="1" name=""/>
+        <p:cNvGrpSpPr/>
+        <p:nvPr/>
+      </p:nvGrpSpPr>
+      <p:grpSpPr>
+        <a:xfrm>
+          <a:off x="0" y="0"/>
+          <a:ext cx="0" cy="0"/>
+          <a:chOff x="0" y="0"/>
+          <a:chExt cx="0" cy="0"/>
+        </a:xfrm>
+      </p:grpSpPr>
+      <p:sp>
+        <p:nvSpPr>
+          <p:cNvPr id="2" name="Title 1">
+            <a:extLst>
+              <a:ext uri="{FF2B5EF4-FFF2-40B4-BE49-F238E27FC236}">
                 <a16:creationId xmlns:a16="http://schemas.microsoft.com/office/drawing/2014/main" id="{6B37C1CA-3968-D957-4CD6-04D88F1572FD}"/>
               </a:ext>
             </a:extLst>
@@ -29456,7 +29546,7 @@
 </p:sld>
 </file>
 
-<file path=ppt/slides/slide11.xml><?xml version="1.0" encoding="utf-8"?>
+<file path=ppt/slides/slide12.xml><?xml version="1.0" encoding="utf-8"?>
 <p:sld xmlns:a="http://schemas.openxmlformats.org/drawingml/2006/main" xmlns:r="http://schemas.openxmlformats.org/officeDocument/2006/relationships" xmlns:p="http://schemas.openxmlformats.org/presentationml/2006/main">
   <p:cSld>
     <p:spTree>
@@ -30857,7 +30947,7 @@
 </p:sld>
 </file>
 
-<file path=ppt/slides/slide12.xml><?xml version="1.0" encoding="utf-8"?>
+<file path=ppt/slides/slide13.xml><?xml version="1.0" encoding="utf-8"?>
 <p:sld xmlns:a="http://schemas.openxmlformats.org/drawingml/2006/main" xmlns:r="http://schemas.openxmlformats.org/officeDocument/2006/relationships" xmlns:p="http://schemas.openxmlformats.org/presentationml/2006/main">
   <p:cSld>
     <p:spTree>
@@ -31895,7 +31985,7 @@
 </p:sld>
 </file>
 
-<file path=ppt/slides/slide13.xml><?xml version="1.0" encoding="utf-8"?>
+<file path=ppt/slides/slide14.xml><?xml version="1.0" encoding="utf-8"?>
 <p:sld xmlns:a="http://schemas.openxmlformats.org/drawingml/2006/main" xmlns:r="http://schemas.openxmlformats.org/officeDocument/2006/relationships" xmlns:p="http://schemas.openxmlformats.org/presentationml/2006/main">
   <p:cSld>
     <p:spTree>
@@ -33012,7 +33102,7 @@
 </p:sld>
 </file>
 
-<file path=ppt/slides/slide14.xml><?xml version="1.0" encoding="utf-8"?>
+<file path=ppt/slides/slide15.xml><?xml version="1.0" encoding="utf-8"?>
 <p:sld xmlns:a="http://schemas.openxmlformats.org/drawingml/2006/main" xmlns:r="http://schemas.openxmlformats.org/officeDocument/2006/relationships" xmlns:p="http://schemas.openxmlformats.org/presentationml/2006/main">
   <p:cSld>
     <p:spTree>
@@ -33132,7 +33222,7 @@
 </p:sld>
 </file>
 
-<file path=ppt/slides/slide15.xml><?xml version="1.0" encoding="utf-8"?>
+<file path=ppt/slides/slide16.xml><?xml version="1.0" encoding="utf-8"?>
 <p:sld xmlns:a="http://schemas.openxmlformats.org/drawingml/2006/main" xmlns:r="http://schemas.openxmlformats.org/officeDocument/2006/relationships" xmlns:p="http://schemas.openxmlformats.org/presentationml/2006/main">
   <p:cSld>
     <p:spTree>
@@ -33223,7 +33313,7 @@
 </p:sld>
 </file>
 
-<file path=ppt/slides/slide16.xml><?xml version="1.0" encoding="utf-8"?>
+<file path=ppt/slides/slide17.xml><?xml version="1.0" encoding="utf-8"?>
 <p:sld xmlns:a="http://schemas.openxmlformats.org/drawingml/2006/main" xmlns:r="http://schemas.openxmlformats.org/officeDocument/2006/relationships" xmlns:p="http://schemas.openxmlformats.org/presentationml/2006/main">
   <p:cSld>
     <p:spTree>
@@ -33312,7 +33402,7 @@
 </p:sld>
 </file>
 
-<file path=ppt/slides/slide17.xml><?xml version="1.0" encoding="utf-8"?>
+<file path=ppt/slides/slide18.xml><?xml version="1.0" encoding="utf-8"?>
 <p:sld xmlns:a="http://schemas.openxmlformats.org/drawingml/2006/main" xmlns:r="http://schemas.openxmlformats.org/officeDocument/2006/relationships" xmlns:p="http://schemas.openxmlformats.org/presentationml/2006/main">
   <p:cSld>
     <p:spTree>
@@ -34459,6 +34549,169 @@
 </file>
 
 <file path=ppt/slides/slide5.xml><?xml version="1.0" encoding="utf-8"?>
+<p:sld xmlns:a="http://schemas.openxmlformats.org/drawingml/2006/main" xmlns:r="http://schemas.openxmlformats.org/officeDocument/2006/relationships" xmlns:p="http://schemas.openxmlformats.org/presentationml/2006/main">
+  <p:cSld>
+    <p:spTree>
+      <p:nvGrpSpPr>
+        <p:cNvPr id="1" name=""/>
+        <p:cNvGrpSpPr/>
+        <p:nvPr/>
+      </p:nvGrpSpPr>
+      <p:grpSpPr>
+        <a:xfrm>
+          <a:off x="0" y="0"/>
+          <a:ext cx="0" cy="0"/>
+          <a:chOff x="0" y="0"/>
+          <a:chExt cx="0" cy="0"/>
+        </a:xfrm>
+      </p:grpSpPr>
+      <p:sp>
+        <p:nvSpPr>
+          <p:cNvPr id="2" name="Title 1">
+            <a:extLst>
+              <a:ext uri="{FF2B5EF4-FFF2-40B4-BE49-F238E27FC236}">
+                <a16:creationId xmlns:a16="http://schemas.microsoft.com/office/drawing/2014/main" id="{963FC3E2-6CD9-138B-40C7-DCB7B26734B1}"/>
+              </a:ext>
+            </a:extLst>
+          </p:cNvPr>
+          <p:cNvSpPr>
+            <a:spLocks noGrp="1"/>
+          </p:cNvSpPr>
+          <p:nvPr>
+            <p:ph type="title"/>
+          </p:nvPr>
+        </p:nvSpPr>
+        <p:spPr>
+          <a:xfrm>
+            <a:off x="457200" y="206375"/>
+            <a:ext cx="8229600" cy="857250"/>
+          </a:xfrm>
+        </p:spPr>
+        <p:txBody>
+          <a:bodyPr anchor="ctr">
+            <a:normAutofit/>
+          </a:bodyPr>
+          <a:lstStyle/>
+          <a:p>
+            <a:r>
+              <a:rPr lang="en-US" dirty="0"/>
+              <a:t>Lab materials</a:t>
+            </a:r>
+          </a:p>
+        </p:txBody>
+      </p:sp>
+      <p:pic>
+        <p:nvPicPr>
+          <p:cNvPr id="5" name="Picture 4">
+            <a:extLst>
+              <a:ext uri="{FF2B5EF4-FFF2-40B4-BE49-F238E27FC236}">
+                <a16:creationId xmlns:a16="http://schemas.microsoft.com/office/drawing/2014/main" id="{776F5AD5-D22A-1947-8E85-616888601895}"/>
+              </a:ext>
+            </a:extLst>
+          </p:cNvPr>
+          <p:cNvPicPr>
+            <a:picLocks noChangeAspect="1"/>
+          </p:cNvPicPr>
+          <p:nvPr/>
+        </p:nvPicPr>
+        <p:blipFill>
+          <a:blip r:embed="rId2" cstate="print">
+            <a:extLst>
+              <a:ext uri="{28A0092B-C50C-407E-A947-70E740481C1C}">
+                <a14:useLocalDpi xmlns:a14="http://schemas.microsoft.com/office/drawing/2010/main" val="0"/>
+              </a:ext>
+            </a:extLst>
+          </a:blip>
+          <a:srcRect t="9809" r="5" b="6154"/>
+          <a:stretch>
+            <a:fillRect/>
+          </a:stretch>
+        </p:blipFill>
+        <p:spPr>
+          <a:xfrm>
+            <a:off x="457200" y="1200150"/>
+            <a:ext cx="4038600" cy="3394075"/>
+          </a:xfrm>
+          <a:prstGeom prst="rect">
+            <a:avLst/>
+          </a:prstGeom>
+          <a:noFill/>
+        </p:spPr>
+      </p:pic>
+      <p:sp>
+        <p:nvSpPr>
+          <p:cNvPr id="3" name="Content Placeholder 2">
+            <a:extLst>
+              <a:ext uri="{FF2B5EF4-FFF2-40B4-BE49-F238E27FC236}">
+                <a16:creationId xmlns:a16="http://schemas.microsoft.com/office/drawing/2014/main" id="{1421760A-CFF0-C26F-9DFC-C52198448E1F}"/>
+              </a:ext>
+            </a:extLst>
+          </p:cNvPr>
+          <p:cNvSpPr>
+            <a:spLocks noGrp="1"/>
+          </p:cNvSpPr>
+          <p:nvPr>
+            <p:ph sz="half" idx="2"/>
+          </p:nvPr>
+        </p:nvSpPr>
+        <p:spPr>
+          <a:xfrm>
+            <a:off x="4648200" y="1200150"/>
+            <a:ext cx="4038600" cy="3394075"/>
+          </a:xfrm>
+        </p:spPr>
+        <p:txBody>
+          <a:bodyPr>
+            <a:normAutofit/>
+          </a:bodyPr>
+          <a:lstStyle/>
+          <a:p>
+            <a:pPr marL="0" indent="0">
+              <a:buNone/>
+            </a:pPr>
+            <a:r>
+              <a:rPr lang="en-US" dirty="0"/>
+              <a:t>Download the Zip file and extract it to a folder on your system.</a:t>
+            </a:r>
+          </a:p>
+          <a:p>
+            <a:pPr marL="0" indent="0">
+              <a:buNone/>
+            </a:pPr>
+            <a:endParaRPr lang="en-US" dirty="0"/>
+          </a:p>
+          <a:p>
+            <a:pPr marL="0" indent="0">
+              <a:buNone/>
+            </a:pPr>
+            <a:r>
+              <a:rPr lang="en-US">
+                <a:hlinkClick r:id="rId3"/>
+              </a:rPr>
+              <a:t>https://bit.ly/THOL01-TM2026</a:t>
+            </a:r>
+            <a:r>
+              <a:rPr lang="en-US"/>
+              <a:t> </a:t>
+            </a:r>
+            <a:endParaRPr lang="en-US" dirty="0"/>
+          </a:p>
+        </p:txBody>
+      </p:sp>
+    </p:spTree>
+    <p:extLst>
+      <p:ext uri="{BB962C8B-B14F-4D97-AF65-F5344CB8AC3E}">
+        <p14:creationId xmlns:p14="http://schemas.microsoft.com/office/powerpoint/2010/main" val="2127810412"/>
+      </p:ext>
+    </p:extLst>
+  </p:cSld>
+  <p:clrMapOvr>
+    <a:masterClrMapping/>
+  </p:clrMapOvr>
+</p:sld>
+</file>
+
+<file path=ppt/slides/slide6.xml><?xml version="1.0" encoding="utf-8"?>
 <p:sld xmlns:a="http://schemas.openxmlformats.org/drawingml/2006/main" xmlns:r="http://schemas.openxmlformats.org/officeDocument/2006/relationships" xmlns:p="http://schemas.openxmlformats.org/presentationml/2006/main">
   <p:cSld>
     <p:spTree>
@@ -35906,7 +36159,7 @@
 </p:sld>
 </file>
 
-<file path=ppt/slides/slide6.xml><?xml version="1.0" encoding="utf-8"?>
+<file path=ppt/slides/slide7.xml><?xml version="1.0" encoding="utf-8"?>
 <p:sld xmlns:a="http://schemas.openxmlformats.org/drawingml/2006/main" xmlns:r="http://schemas.openxmlformats.org/officeDocument/2006/relationships" xmlns:p="http://schemas.openxmlformats.org/presentationml/2006/main">
   <p:cSld>
     <p:spTree>
@@ -35997,7 +36250,7 @@
 </p:sld>
 </file>
 
-<file path=ppt/slides/slide7.xml><?xml version="1.0" encoding="utf-8"?>
+<file path=ppt/slides/slide8.xml><?xml version="1.0" encoding="utf-8"?>
 <p:sld xmlns:a="http://schemas.openxmlformats.org/drawingml/2006/main" xmlns:r="http://schemas.openxmlformats.org/officeDocument/2006/relationships" xmlns:p="http://schemas.openxmlformats.org/presentationml/2006/main">
   <p:cSld>
     <p:spTree>
@@ -36935,7 +37188,7 @@
 </p:sld>
 </file>
 
-<file path=ppt/slides/slide8.xml><?xml version="1.0" encoding="utf-8"?>
+<file path=ppt/slides/slide9.xml><?xml version="1.0" encoding="utf-8"?>
 <p:sld xmlns:a="http://schemas.openxmlformats.org/drawingml/2006/main" xmlns:r="http://schemas.openxmlformats.org/officeDocument/2006/relationships" xmlns:p="http://schemas.openxmlformats.org/presentationml/2006/main">
   <p:cSld>
     <p:spTree>
@@ -37017,95 +37270,6 @@
     <p:extLst>
       <p:ext uri="{BB962C8B-B14F-4D97-AF65-F5344CB8AC3E}">
         <p14:creationId xmlns:p14="http://schemas.microsoft.com/office/powerpoint/2010/main" val="3218458389"/>
-      </p:ext>
-    </p:extLst>
-  </p:cSld>
-  <p:clrMapOvr>
-    <a:masterClrMapping/>
-  </p:clrMapOvr>
-</p:sld>
-</file>
-
-<file path=ppt/slides/slide9.xml><?xml version="1.0" encoding="utf-8"?>
-<p:sld xmlns:a="http://schemas.openxmlformats.org/drawingml/2006/main" xmlns:r="http://schemas.openxmlformats.org/officeDocument/2006/relationships" xmlns:p="http://schemas.openxmlformats.org/presentationml/2006/main">
-  <p:cSld>
-    <p:spTree>
-      <p:nvGrpSpPr>
-        <p:cNvPr id="1" name=""/>
-        <p:cNvGrpSpPr/>
-        <p:nvPr/>
-      </p:nvGrpSpPr>
-      <p:grpSpPr>
-        <a:xfrm>
-          <a:off x="0" y="0"/>
-          <a:ext cx="0" cy="0"/>
-          <a:chOff x="0" y="0"/>
-          <a:chExt cx="0" cy="0"/>
-        </a:xfrm>
-      </p:grpSpPr>
-      <p:sp>
-        <p:nvSpPr>
-          <p:cNvPr id="2" name="Title 1">
-            <a:extLst>
-              <a:ext uri="{FF2B5EF4-FFF2-40B4-BE49-F238E27FC236}">
-                <a16:creationId xmlns:a16="http://schemas.microsoft.com/office/drawing/2014/main" id="{B53E042C-9C01-11B7-FADC-AF3C17430252}"/>
-              </a:ext>
-            </a:extLst>
-          </p:cNvPr>
-          <p:cNvSpPr>
-            <a:spLocks noGrp="1"/>
-          </p:cNvSpPr>
-          <p:nvPr>
-            <p:ph type="title"/>
-          </p:nvPr>
-        </p:nvSpPr>
-        <p:spPr/>
-        <p:txBody>
-          <a:bodyPr/>
-          <a:lstStyle/>
-          <a:p>
-            <a:r>
-              <a:rPr lang="en-US" dirty="0"/>
-              <a:t>Command design</a:t>
-            </a:r>
-          </a:p>
-        </p:txBody>
-      </p:sp>
-      <p:graphicFrame>
-        <p:nvGraphicFramePr>
-          <p:cNvPr id="4" name="Content Placeholder 3">
-            <a:extLst>
-              <a:ext uri="{FF2B5EF4-FFF2-40B4-BE49-F238E27FC236}">
-                <a16:creationId xmlns:a16="http://schemas.microsoft.com/office/drawing/2014/main" id="{0114C13B-9F4B-1331-0A9E-CBD62A44A869}"/>
-              </a:ext>
-            </a:extLst>
-          </p:cNvPr>
-          <p:cNvGraphicFramePr>
-            <a:graphicFrameLocks noGrp="1"/>
-          </p:cNvGraphicFramePr>
-          <p:nvPr>
-            <p:ph idx="1"/>
-            <p:extLst>
-              <p:ext uri="{D42A27DB-BD31-4B8C-83A1-F6EECF244321}">
-                <p14:modId xmlns:p14="http://schemas.microsoft.com/office/powerpoint/2010/main" val="1789930414"/>
-              </p:ext>
-            </p:extLst>
-          </p:nvPr>
-        </p:nvGraphicFramePr>
-        <p:xfrm>
-          <a:off x="457200" y="1200150"/>
-          <a:ext cx="8229600" cy="3394075"/>
-        </p:xfrm>
-        <a:graphic>
-          <a:graphicData uri="http://schemas.openxmlformats.org/drawingml/2006/diagram">
-            <dgm:relIds xmlns:dgm="http://schemas.openxmlformats.org/drawingml/2006/diagram" xmlns:r="http://schemas.openxmlformats.org/officeDocument/2006/relationships" r:dm="rId2" r:lo="rId3" r:qs="rId4" r:cs="rId5"/>
-          </a:graphicData>
-        </a:graphic>
-      </p:graphicFrame>
-    </p:spTree>
-    <p:extLst>
-      <p:ext uri="{BB962C8B-B14F-4D97-AF65-F5344CB8AC3E}">
-        <p14:creationId xmlns:p14="http://schemas.microsoft.com/office/powerpoint/2010/main" val="1497520819"/>
       </p:ext>
     </p:extLst>
   </p:cSld>
@@ -38033,4 +38197,10 @@
   <a:objectDefaults/>
   <a:extraClrSchemeLst/>
 </a:theme>
+</file>
+
+<file path=docMetadata/LabelInfo.xml><?xml version="1.0" encoding="utf-8"?>
+<clbl:labelList xmlns:clbl="http://schemas.microsoft.com/office/2020/mipLabelMetadata">
+  <clbl:label id="{f42aa342-8706-4288-bd11-ebb85995028c}" enabled="1" method="Standard" siteId="{72f988bf-86f1-41af-91ab-2d7cd011db47}" contentBits="0" removed="0"/>
+</clbl:labelList>
 </file>
</xml_diff>